<commit_message>
Fix presentation framing: address judges as the client
Slides now use second-person ("your mission", "you told us") since
judges role-play as the client. Removed third-person references
to "our client" and Lighthouse Sanctuary background they already know.

Co-Authored-By: Claude Opus 4.6 (1M context) <noreply@anthropic.com>
</commit_message>
<xml_diff>
--- a/presentation/New_Dawn_Presentation.pptx
+++ b/presentation/New_Dawn_Presentation.pptx
@@ -3791,7 +3791,44 @@
         </p:nvSpPr>
         <p:spPr>
           <a:xfrm>
-            <a:off x="1371600" y="1097280"/>
+            <a:off x="1371600" y="914400"/>
+            <a:ext cx="9418320" cy="457200"/>
+          </a:xfrm>
+          <a:prstGeom prst="rect">
+            <a:avLst/>
+          </a:prstGeom>
+          <a:noFill/>
+        </p:spPr>
+        <p:txBody>
+          <a:bodyPr wrap="square"/>
+          <a:lstStyle/>
+          <a:p>
+            <a:pPr algn="ctr">
+              <a:lnSpc>
+                <a:spcPts val="1600"/>
+              </a:lnSpc>
+              <a:defRPr sz="1400" b="1">
+                <a:solidFill>
+                  <a:srgbClr val="FFCC66"/>
+                </a:solidFill>
+                <a:latin typeface="Calibri"/>
+              </a:defRPr>
+            </a:pPr>
+            <a:r>
+              <a:t>YOUR MISSION</a:t>
+            </a:r>
+          </a:p>
+        </p:txBody>
+      </p:sp>
+      <p:sp>
+        <p:nvSpPr>
+          <p:cNvPr id="4" name="TextBox 3"/>
+          <p:cNvSpPr txBox="1"/>
+          <p:nvPr/>
+        </p:nvSpPr>
+        <p:spPr>
+          <a:xfrm>
+            <a:off x="1371600" y="1463040"/>
             <a:ext cx="9418320" cy="1097280"/>
           </a:xfrm>
           <a:prstGeom prst="rect">
@@ -3805,9 +3842,9 @@
           <a:p>
             <a:pPr algn="ctr">
               <a:lnSpc>
-                <a:spcPts val="4200"/>
-              </a:lnSpc>
-              <a:defRPr sz="2800" b="0">
+                <a:spcPts val="3900"/>
+              </a:lnSpc>
+              <a:defRPr sz="2600" b="0">
                 <a:solidFill>
                   <a:srgbClr val="DDDDDD"/>
                 </a:solidFill>
@@ -3815,24 +3852,24 @@
               </a:defRPr>
             </a:pPr>
             <a:r>
-              <a:t>In the Philippines, thousands of girls are survivors of</a:t>
+              <a:t>You're building an organization to provide safe homes for girls</a:t>
             </a:r>
             <a:br/>
             <a:r>
-              <a:t>sexual abuse and trafficking.</a:t>
-            </a:r>
-          </a:p>
-        </p:txBody>
-      </p:sp>
-      <p:sp>
-        <p:nvSpPr>
-          <p:cNvPr id="4" name="TextBox 3"/>
-          <p:cNvSpPr txBox="1"/>
-          <p:nvPr/>
-        </p:nvSpPr>
-        <p:spPr>
-          <a:xfrm>
-            <a:off x="1371600" y="2377440"/>
+              <a:t>who are survivors of sexual abuse and trafficking in the Philippines.</a:t>
+            </a:r>
+          </a:p>
+        </p:txBody>
+      </p:sp>
+      <p:sp>
+        <p:nvSpPr>
+          <p:cNvPr id="5" name="TextBox 4"/>
+          <p:cNvSpPr txBox="1"/>
+          <p:nvPr/>
+        </p:nvSpPr>
+        <p:spPr>
+          <a:xfrm>
+            <a:off x="1371600" y="2743200"/>
             <a:ext cx="9418320" cy="640080"/>
           </a:xfrm>
           <a:prstGeom prst="rect">
@@ -3848,28 +3885,28 @@
               <a:lnSpc>
                 <a:spcPts val="2600"/>
               </a:lnSpc>
-              <a:defRPr sz="2200" b="0">
-                <a:solidFill>
-                  <a:srgbClr val="999999"/>
+              <a:defRPr sz="2200" b="1">
+                <a:solidFill>
+                  <a:srgbClr val="A2C9E1"/>
                 </a:solidFill>
                 <a:latin typeface="Calibri Light"/>
               </a:defRPr>
             </a:pPr>
             <a:r>
-              <a:t>Many are minors. Many have nowhere safe to go.</a:t>
-            </a:r>
-          </a:p>
-        </p:txBody>
-      </p:sp>
-      <p:sp>
-        <p:nvSpPr>
-          <p:cNvPr id="5" name="Rectangle 4"/>
+              <a:t>Caring. Healing. Teaching.</a:t>
+            </a:r>
+          </a:p>
+        </p:txBody>
+      </p:sp>
+      <p:sp>
+        <p:nvSpPr>
+          <p:cNvPr id="6" name="Rectangle 5"/>
           <p:cNvSpPr/>
           <p:nvPr/>
         </p:nvSpPr>
         <p:spPr>
           <a:xfrm>
-            <a:off x="5303520" y="3291840"/>
+            <a:off x="5303520" y="3474720"/>
             <a:ext cx="1554480" cy="25400"/>
           </a:xfrm>
           <a:prstGeom prst="rect">
@@ -3906,13 +3943,13 @@
       </p:sp>
       <p:sp>
         <p:nvSpPr>
-          <p:cNvPr id="6" name="TextBox 5"/>
-          <p:cNvSpPr txBox="1"/>
-          <p:nvPr/>
-        </p:nvSpPr>
-        <p:spPr>
-          <a:xfrm>
-            <a:off x="1371600" y="3657600"/>
+          <p:cNvPr id="7" name="TextBox 6"/>
+          <p:cNvSpPr txBox="1"/>
+          <p:nvPr/>
+        </p:nvSpPr>
+        <p:spPr>
+          <a:xfrm>
+            <a:off x="1371600" y="3840480"/>
             <a:ext cx="9418320" cy="1371600"/>
           </a:xfrm>
           <a:prstGeom prst="rect">
@@ -3936,29 +3973,29 @@
               </a:defRPr>
             </a:pPr>
             <a:r>
-              <a:t>Organizations like Lighthouse Sanctuary operate safe homes</a:t>
+              <a:t>Shelter, counseling, education, and reintegration</a:t>
             </a:r>
             <a:br/>
             <a:r>
-              <a:t>where these girls can begin to heal -- through shelter, counseling,</a:t>
+              <a:t>for the most vulnerable -- with limited staff, limited budget,</a:t>
             </a:r>
             <a:br/>
             <a:r>
-              <a:t>education, and eventually, reintegration into safe communities.</a:t>
-            </a:r>
-          </a:p>
-        </p:txBody>
-      </p:sp>
-      <p:sp>
-        <p:nvSpPr>
-          <p:cNvPr id="7" name="TextBox 6"/>
-          <p:cNvSpPr txBox="1"/>
-          <p:nvPr/>
-        </p:nvSpPr>
-        <p:spPr>
-          <a:xfrm>
-            <a:off x="1371600" y="5120640"/>
-            <a:ext cx="9418320" cy="914400"/>
+              <a:t>and data that could be saving lives if you had the tools to use it.</a:t>
+            </a:r>
+          </a:p>
+        </p:txBody>
+      </p:sp>
+      <p:sp>
+        <p:nvSpPr>
+          <p:cNvPr id="8" name="TextBox 7"/>
+          <p:cNvSpPr txBox="1"/>
+          <p:nvPr/>
+        </p:nvSpPr>
+        <p:spPr>
+          <a:xfrm>
+            <a:off x="1371600" y="5303520"/>
+            <a:ext cx="9418320" cy="548640"/>
           </a:xfrm>
           <a:prstGeom prst="rect">
             <a:avLst/>
@@ -3971,34 +4008,30 @@
           <a:p>
             <a:pPr algn="ctr">
               <a:lnSpc>
-                <a:spcPts val="3000"/>
-              </a:lnSpc>
-              <a:defRPr sz="2000" b="0">
-                <a:solidFill>
-                  <a:srgbClr val="A2C9E1"/>
+                <a:spcPts val="2600"/>
+              </a:lnSpc>
+              <a:defRPr sz="2200" b="1">
+                <a:solidFill>
+                  <a:srgbClr val="FFCC66"/>
                 </a:solidFill>
                 <a:latin typeface="Calibri Light"/>
               </a:defRPr>
             </a:pPr>
             <a:r>
-              <a:t>Our client is building a new organization to extend this work</a:t>
-            </a:r>
-            <a:br/>
-            <a:r>
-              <a:t>into regions where these services don't yet exist.</a:t>
-            </a:r>
-          </a:p>
-        </p:txBody>
-      </p:sp>
-      <p:sp>
-        <p:nvSpPr>
-          <p:cNvPr id="8" name="TextBox 7"/>
-          <p:cNvSpPr txBox="1"/>
-          <p:nvPr/>
-        </p:nvSpPr>
-        <p:spPr>
-          <a:xfrm>
-            <a:off x="1371600" y="5943600"/>
+              <a:t>You asked us to build those tools.</a:t>
+            </a:r>
+          </a:p>
+        </p:txBody>
+      </p:sp>
+      <p:sp>
+        <p:nvSpPr>
+          <p:cNvPr id="9" name="TextBox 8"/>
+          <p:cNvSpPr txBox="1"/>
+          <p:nvPr/>
+        </p:nvSpPr>
+        <p:spPr>
+          <a:xfrm>
+            <a:off x="1371600" y="5852160"/>
             <a:ext cx="9418320" cy="548640"/>
           </a:xfrm>
           <a:prstGeom prst="rect">
@@ -4016,20 +4049,20 @@
               </a:lnSpc>
               <a:defRPr sz="1800" b="0">
                 <a:solidFill>
-                  <a:srgbClr val="FFCC66"/>
+                  <a:srgbClr val="999999"/>
                 </a:solidFill>
                 <a:latin typeface="Calibri Light"/>
               </a:defRPr>
             </a:pPr>
             <a:r>
-              <a:t>They asked us to build the technology to help them do it.</a:t>
-            </a:r>
-          </a:p>
-        </p:txBody>
-      </p:sp>
-      <p:sp>
-        <p:nvSpPr>
-          <p:cNvPr id="9" name="TextBox 8"/>
+              <a:t>This is what we built.</a:t>
+            </a:r>
+          </a:p>
+        </p:txBody>
+      </p:sp>
+      <p:sp>
+        <p:nvSpPr>
+          <p:cNvPr id="10" name="TextBox 9"/>
           <p:cNvSpPr txBox="1"/>
           <p:nvPr/>
         </p:nvSpPr>
@@ -4165,7 +4198,7 @@
               </a:defRPr>
             </a:pPr>
             <a:r>
-              <a:t>WHAT THEY TOLD US</a:t>
+              <a:t>WHAT YOU SHARED WITH US</a:t>
             </a:r>
           </a:p>
         </p:txBody>
@@ -4202,7 +4235,7 @@
               </a:defRPr>
             </a:pPr>
             <a:r>
-              <a:t>Three Things That Keep Them Up at Night</a:t>
+              <a:t>Three Things That Keep You Up at Night</a:t>
             </a:r>
           </a:p>
         </p:txBody>
@@ -4409,7 +4442,7 @@
               </a:defRPr>
             </a:pPr>
             <a:r>
-              <a:t>With limited staff across multiple safehouses, they can't always see which girls are progressing and which are struggling. They have no way to predict when someone is ready for reintegration -- or at risk of regression.</a:t>
+              <a:t>With limited staff across multiple safehouses, you can't always see which girls are progressing and which are struggling. There's no way to predict when someone is ready for reintegration -- or at risk of regression.</a:t>
             </a:r>
           </a:p>
         </p:txBody>
@@ -4573,7 +4606,7 @@
               </a:defRPr>
             </a:pPr>
             <a:r>
-              <a:t>Social media is their primary channel for reaching donors, but the founders freely admit they aren't experienced with it. They post sporadically and can't tell what actually drives donations versus just generating likes.</a:t>
+              <a:t>Social media is your primary channel for reaching donors, but you've told us you aren't experienced with it. You post sporadically and can't tell what actually drives donations versus just generating likes.</a:t>
             </a:r>
           </a:p>
         </p:txBody>
@@ -4737,7 +4770,7 @@
               </a:defRPr>
             </a:pPr>
             <a:r>
-              <a:t>The organization depends entirely on donations. They run fundraising campaigns but aren't sure which ones move the needle. They want to know which donors might give more, which are at risk of lapsing, and how to personalize outreach without a marketing team.</a:t>
+              <a:t>Your organization depends entirely on donations. You run fundraising campaigns but aren't sure which ones move the needle. You want to know which donors might give more, which are at risk of lapsing, and how to personalize outreach without a marketing team.</a:t>
             </a:r>
           </a:p>
         </p:txBody>

</xml_diff>

<commit_message>
Update slides 3-4 to match actual features built
Solution 2 now reflects full AI editor (generation, chat refinement,
media upload, platform previews, draft saving) not just predictions.
Solution 1/3 mention notification system. Demo slide updated with
accurate Social Editor workflow and admin notifications.

Co-Authored-By: Claude Opus 4.6 (1M context) <noreply@anthropic.com>
</commit_message>
<xml_diff>
--- a/presentation/New_Dawn_Presentation.pptx
+++ b/presentation/New_Dawn_Presentation.pptx
@@ -5194,7 +5194,7 @@
               </a:defRPr>
             </a:pPr>
             <a:r>
-              <a:t>ML-powered risk prediction and causal reintegration analysis so no girl goes unnoticed.</a:t>
+              <a:t>ML risk prediction flags at-risk residents before they regress. Causal analysis identifies which factors actually drive successful reintegration. Automated notifications alert staff to forgotten cases.</a:t>
             </a:r>
           </a:p>
         </p:txBody>
@@ -5231,7 +5231,7 @@
               </a:defRPr>
             </a:pPr>
             <a:r>
-              <a:t>Risk Prediction + Reintegration Causal</a:t>
+              <a:t>Risk Prediction + Reintegration Causal + Notifications</a:t>
             </a:r>
           </a:p>
         </p:txBody>
@@ -5391,7 +5391,7 @@
               </a:defRPr>
             </a:pPr>
             <a:r>
-              <a:t>Real-time ML predictions show expected donations and engagement as staff craft posts. Optimal posting times maximize impact.</a:t>
+              <a:t>AI generates and refines social media posts via interactive chat. ML predicts donations, engagement, and reach in real time. Optimal posting times maximize fundraising. Save drafts, upload media, preview per platform.</a:t>
             </a:r>
           </a:p>
         </p:txBody>
@@ -5428,7 +5428,7 @@
               </a:defRPr>
             </a:pPr>
             <a:r>
-              <a:t>Social Referrals + Best Posting Times</a:t>
+              <a:t>AI Generation + Referral Predictions + Best Posting Times</a:t>
             </a:r>
           </a:p>
         </p:txBody>
@@ -5588,7 +5588,7 @@
               </a:defRPr>
             </a:pPr>
             <a:r>
-              <a:t>ML predicts which donors are likely to give again with explainable reasons, so staff can prioritize outreach.</a:t>
+              <a:t>ML predicts which donors are likely to give again within 6 months, with SHAP-driven reasons explaining each score. Automated alerts flag declining donors so staff can act before they lapse.</a:t>
             </a:r>
           </a:p>
         </p:txBody>
@@ -5625,7 +5625,7 @@
               </a:defRPr>
             </a:pPr>
             <a:r>
-              <a:t>Donor Likelihood Prediction</a:t>
+              <a:t>Donor Likelihood Prediction + Decline Notifications</a:t>
             </a:r>
           </a:p>
         </p:txBody>
@@ -6223,7 +6223,7 @@
                 </a:solidFill>
                 <a:latin typeface="Calibri"/>
               </a:rPr>
-              <a:t>Admin Dashboard -- active residents, donations, interventions overview</a:t>
+              <a:t>Admin Dashboard -- residents, donations, OKR metric, reintegration insights</a:t>
             </a:r>
           </a:p>
           <a:p>
@@ -6248,7 +6248,7 @@
                 </a:solidFill>
                 <a:latin typeface="Calibri"/>
               </a:rPr>
-              <a:t>Role-based access: Admin sees all, Donor sees own data only</a:t>
+              <a:t>Notification bell -- alerts for at-risk donors, forgotten cases, milestones</a:t>
             </a:r>
           </a:p>
           <a:p>
@@ -6273,7 +6273,7 @@
                 </a:solidFill>
                 <a:latin typeface="Calibri"/>
               </a:rPr>
-              <a:t>Delete confirmation modals, pagination on every list</a:t>
+              <a:t>Role-based access, delete confirmations, pagination on every list</a:t>
             </a:r>
           </a:p>
         </p:txBody>
@@ -6937,7 +6937,7 @@
                 </a:solidFill>
                 <a:latin typeface="Calibri"/>
               </a:rPr>
-              <a:t>Build a post: pick platform, type, media, topic, sentiment, CTA</a:t>
+              <a:t>Fill out a brief (platform, topic, CTA, tone) then AI generates the post</a:t>
             </a:r>
           </a:p>
           <a:p>
@@ -6962,7 +6962,7 @@
                 </a:solidFill>
                 <a:latin typeface="Calibri"/>
               </a:rPr>
-              <a:t>Watch 6 prediction cards update live (referrals, value, engagement...)</a:t>
+              <a:t>Refine via AI chat -- ask it to adjust tone, add hashtags, etc.</a:t>
             </a:r>
           </a:p>
           <a:p>
@@ -6987,7 +6987,7 @@
                 </a:solidFill>
                 <a:latin typeface="Calibri"/>
               </a:rPr>
-              <a:t>Change platform or CTA -- narrate how predictions shift</a:t>
+              <a:t>Upload media and see platform-specific previews (IG Reel, TikTok, etc.)</a:t>
             </a:r>
           </a:p>
           <a:p>
@@ -7012,7 +7012,7 @@
                 </a:solidFill>
                 <a:latin typeface="Calibri"/>
               </a:rPr>
-              <a:t>Show Best Posting Times -- top 15 optimal day/hour slots</a:t>
+              <a:t>Predict Performance: 6 ML metrics update (referrals, value, engagement...)</a:t>
             </a:r>
           </a:p>
           <a:p>
@@ -7037,7 +7037,7 @@
                 </a:solidFill>
                 <a:latin typeface="Calibri"/>
               </a:rPr>
-              <a:t>Click an optimal slot to auto-schedule the post</a:t>
+              <a:t>Suggest Times: ML-ranked optimal day/hour slots, click to schedule</a:t>
             </a:r>
           </a:p>
         </p:txBody>

</xml_diff>